<commit_message>
fix(orchestrator): non-blocking turns, elevenlabs api integration, and resilient audio watchdog
</commit_message>
<xml_diff>
--- a/ppt_airoundtable.pptx
+++ b/ppt_airoundtable.pptx
@@ -5,14 +5,14 @@
     <p:sldMasterId id="2147483648" r:id="rId1"/>
   </p:sldMasterIdLst>
   <p:sldIdLst>
-    <p:sldId id="256" r:id="rId7"/>
-    <p:sldId id="257" r:id="rId8"/>
-    <p:sldId id="258" r:id="rId9"/>
-    <p:sldId id="259" r:id="rId10"/>
-    <p:sldId id="260" r:id="rId11"/>
-    <p:sldId id="261" r:id="rId12"/>
+    <p:sldId id="256" r:id="rId2"/>
+    <p:sldId id="257" r:id="rId3"/>
+    <p:sldId id="258" r:id="rId4"/>
+    <p:sldId id="259" r:id="rId5"/>
+    <p:sldId id="260" r:id="rId6"/>
+    <p:sldId id="261" r:id="rId7"/>
   </p:sldIdLst>
-  <p:sldSz cx="12191695" cy="6858000" type="screen4x3"/>
+  <p:sldSz cx="12192000" cy="6858000"/>
   <p:notesSz cx="6858000" cy="9144000"/>
   <p:defaultTextStyle>
     <a:defPPr>
@@ -109,7 +109,200 @@
       </a:defRPr>
     </a:lvl9pPr>
   </p:defaultTextStyle>
+  <p:extLst>
+    <p:ext uri="{EFAFB233-063F-42B5-8137-9DF3F51BA10A}">
+      <p15:sldGuideLst xmlns:p15="http://schemas.microsoft.com/office/powerpoint/2012/main">
+        <p15:guide id="1" orient="horz" pos="2160">
+          <p15:clr>
+            <a:srgbClr val="A4A3A4"/>
+          </p15:clr>
+        </p15:guide>
+        <p15:guide id="2" pos="2880">
+          <p15:clr>
+            <a:srgbClr val="A4A3A4"/>
+          </p15:clr>
+        </p15:guide>
+      </p15:sldGuideLst>
+    </p:ext>
+  </p:extLst>
 </p:presentation>
+</file>
+
+<file path=ppt/revisionInfo.xml><?xml version="1.0" encoding="utf-8"?>
+<p1510:revInfo xmlns:a="http://schemas.openxmlformats.org/drawingml/2006/main" xmlns:r="http://schemas.openxmlformats.org/officeDocument/2006/relationships" xmlns:p1510="http://schemas.microsoft.com/office/powerpoint/2015/10/main">
+  <p1510:revLst>
+    <p1510:client id="{5425B482-61F4-4DCF-8577-E67B181249F7}" v="3" dt="2026-10-22T06:32:50.176"/>
+  </p1510:revLst>
+</p1510:revInfo>
+</file>
+
+<file path=ppt/changesInfos/changesInfo1.xml><?xml version="1.0" encoding="utf-8"?>
+<pc:chgInfo xmlns:a="http://schemas.openxmlformats.org/drawingml/2006/main" xmlns:r="http://schemas.openxmlformats.org/officeDocument/2006/relationships" xmlns:ac="http://schemas.microsoft.com/office/drawing/2013/main/command" xmlns:pc="http://schemas.microsoft.com/office/powerpoint/2013/main/command">
+  <pc:docChgLst>
+    <pc:chgData name="Aryan Vats" userId="3cc5273a2db24fe5" providerId="LiveId" clId="{69076714-F7C0-4B87-826A-CD5C4A783D1F}"/>
+    <pc:docChg chg="undo custSel addSld delSld modSld">
+      <pc:chgData name="Aryan Vats" userId="3cc5273a2db24fe5" providerId="LiveId" clId="{69076714-F7C0-4B87-826A-CD5C4A783D1F}" dt="2026-10-22T06:33:42.812" v="143" actId="47"/>
+      <pc:docMkLst>
+        <pc:docMk/>
+      </pc:docMkLst>
+      <pc:sldChg chg="modSp mod">
+        <pc:chgData name="Aryan Vats" userId="3cc5273a2db24fe5" providerId="LiveId" clId="{69076714-F7C0-4B87-826A-CD5C4A783D1F}" dt="2026-10-22T06:33:39.062" v="142" actId="1076"/>
+        <pc:sldMkLst>
+          <pc:docMk/>
+          <pc:sldMk cId="0" sldId="256"/>
+        </pc:sldMkLst>
+        <pc:spChg chg="mod">
+          <ac:chgData name="Aryan Vats" userId="3cc5273a2db24fe5" providerId="LiveId" clId="{69076714-F7C0-4B87-826A-CD5C4A783D1F}" dt="2026-10-22T06:32:54.178" v="139" actId="20577"/>
+          <ac:spMkLst>
+            <pc:docMk/>
+            <pc:sldMk cId="0" sldId="256"/>
+            <ac:spMk id="4" creationId="{00000000-0000-0000-0000-000000000000}"/>
+          </ac:spMkLst>
+        </pc:spChg>
+        <pc:spChg chg="mod">
+          <ac:chgData name="Aryan Vats" userId="3cc5273a2db24fe5" providerId="LiveId" clId="{69076714-F7C0-4B87-826A-CD5C4A783D1F}" dt="2026-10-22T06:33:22.476" v="140" actId="1076"/>
+          <ac:spMkLst>
+            <pc:docMk/>
+            <pc:sldMk cId="0" sldId="256"/>
+            <ac:spMk id="5" creationId="{00000000-0000-0000-0000-000000000000}"/>
+          </ac:spMkLst>
+        </pc:spChg>
+        <pc:spChg chg="mod">
+          <ac:chgData name="Aryan Vats" userId="3cc5273a2db24fe5" providerId="LiveId" clId="{69076714-F7C0-4B87-826A-CD5C4A783D1F}" dt="2026-10-22T06:33:22.476" v="140" actId="1076"/>
+          <ac:spMkLst>
+            <pc:docMk/>
+            <pc:sldMk cId="0" sldId="256"/>
+            <ac:spMk id="6" creationId="{00000000-0000-0000-0000-000000000000}"/>
+          </ac:spMkLst>
+        </pc:spChg>
+        <pc:spChg chg="mod">
+          <ac:chgData name="Aryan Vats" userId="3cc5273a2db24fe5" providerId="LiveId" clId="{69076714-F7C0-4B87-826A-CD5C4A783D1F}" dt="2026-10-22T06:33:22.476" v="140" actId="1076"/>
+          <ac:spMkLst>
+            <pc:docMk/>
+            <pc:sldMk cId="0" sldId="256"/>
+            <ac:spMk id="7" creationId="{00000000-0000-0000-0000-000000000000}"/>
+          </ac:spMkLst>
+        </pc:spChg>
+        <pc:spChg chg="mod">
+          <ac:chgData name="Aryan Vats" userId="3cc5273a2db24fe5" providerId="LiveId" clId="{69076714-F7C0-4B87-826A-CD5C4A783D1F}" dt="2026-10-22T06:33:22.476" v="140" actId="1076"/>
+          <ac:spMkLst>
+            <pc:docMk/>
+            <pc:sldMk cId="0" sldId="256"/>
+            <ac:spMk id="8" creationId="{00000000-0000-0000-0000-000000000000}"/>
+          </ac:spMkLst>
+        </pc:spChg>
+        <pc:spChg chg="mod">
+          <ac:chgData name="Aryan Vats" userId="3cc5273a2db24fe5" providerId="LiveId" clId="{69076714-F7C0-4B87-826A-CD5C4A783D1F}" dt="2026-10-22T06:33:22.476" v="140" actId="1076"/>
+          <ac:spMkLst>
+            <pc:docMk/>
+            <pc:sldMk cId="0" sldId="256"/>
+            <ac:spMk id="9" creationId="{00000000-0000-0000-0000-000000000000}"/>
+          </ac:spMkLst>
+        </pc:spChg>
+        <pc:spChg chg="mod">
+          <ac:chgData name="Aryan Vats" userId="3cc5273a2db24fe5" providerId="LiveId" clId="{69076714-F7C0-4B87-826A-CD5C4A783D1F}" dt="2026-10-22T06:33:22.476" v="140" actId="1076"/>
+          <ac:spMkLst>
+            <pc:docMk/>
+            <pc:sldMk cId="0" sldId="256"/>
+            <ac:spMk id="10" creationId="{00000000-0000-0000-0000-000000000000}"/>
+          </ac:spMkLst>
+        </pc:spChg>
+        <pc:spChg chg="mod">
+          <ac:chgData name="Aryan Vats" userId="3cc5273a2db24fe5" providerId="LiveId" clId="{69076714-F7C0-4B87-826A-CD5C4A783D1F}" dt="2026-10-22T06:33:22.476" v="140" actId="1076"/>
+          <ac:spMkLst>
+            <pc:docMk/>
+            <pc:sldMk cId="0" sldId="256"/>
+            <ac:spMk id="11" creationId="{00000000-0000-0000-0000-000000000000}"/>
+          </ac:spMkLst>
+        </pc:spChg>
+        <pc:spChg chg="mod">
+          <ac:chgData name="Aryan Vats" userId="3cc5273a2db24fe5" providerId="LiveId" clId="{69076714-F7C0-4B87-826A-CD5C4A783D1F}" dt="2026-10-22T06:33:22.476" v="140" actId="1076"/>
+          <ac:spMkLst>
+            <pc:docMk/>
+            <pc:sldMk cId="0" sldId="256"/>
+            <ac:spMk id="12" creationId="{00000000-0000-0000-0000-000000000000}"/>
+          </ac:spMkLst>
+        </pc:spChg>
+        <pc:spChg chg="mod">
+          <ac:chgData name="Aryan Vats" userId="3cc5273a2db24fe5" providerId="LiveId" clId="{69076714-F7C0-4B87-826A-CD5C4A783D1F}" dt="2026-10-22T06:33:22.476" v="140" actId="1076"/>
+          <ac:spMkLst>
+            <pc:docMk/>
+            <pc:sldMk cId="0" sldId="256"/>
+            <ac:spMk id="13" creationId="{00000000-0000-0000-0000-000000000000}"/>
+          </ac:spMkLst>
+        </pc:spChg>
+        <pc:spChg chg="mod">
+          <ac:chgData name="Aryan Vats" userId="3cc5273a2db24fe5" providerId="LiveId" clId="{69076714-F7C0-4B87-826A-CD5C4A783D1F}" dt="2026-10-22T06:33:39.062" v="142" actId="1076"/>
+          <ac:spMkLst>
+            <pc:docMk/>
+            <pc:sldMk cId="0" sldId="256"/>
+            <ac:spMk id="15" creationId="{00000000-0000-0000-0000-000000000000}"/>
+          </ac:spMkLst>
+        </pc:spChg>
+      </pc:sldChg>
+      <pc:sldChg chg="modSp mod">
+        <pc:chgData name="Aryan Vats" userId="3cc5273a2db24fe5" providerId="LiveId" clId="{69076714-F7C0-4B87-826A-CD5C4A783D1F}" dt="2026-10-22T06:31:15.486" v="4" actId="207"/>
+        <pc:sldMkLst>
+          <pc:docMk/>
+          <pc:sldMk cId="0" sldId="258"/>
+        </pc:sldMkLst>
+        <pc:spChg chg="mod">
+          <ac:chgData name="Aryan Vats" userId="3cc5273a2db24fe5" providerId="LiveId" clId="{69076714-F7C0-4B87-826A-CD5C4A783D1F}" dt="2026-10-22T06:31:02.238" v="0" actId="207"/>
+          <ac:spMkLst>
+            <pc:docMk/>
+            <pc:sldMk cId="0" sldId="258"/>
+            <ac:spMk id="6" creationId="{00000000-0000-0000-0000-000000000000}"/>
+          </ac:spMkLst>
+        </pc:spChg>
+        <pc:spChg chg="mod">
+          <ac:chgData name="Aryan Vats" userId="3cc5273a2db24fe5" providerId="LiveId" clId="{69076714-F7C0-4B87-826A-CD5C4A783D1F}" dt="2026-10-22T06:31:11.910" v="3" actId="207"/>
+          <ac:spMkLst>
+            <pc:docMk/>
+            <pc:sldMk cId="0" sldId="258"/>
+            <ac:spMk id="9" creationId="{00000000-0000-0000-0000-000000000000}"/>
+          </ac:spMkLst>
+        </pc:spChg>
+        <pc:spChg chg="mod">
+          <ac:chgData name="Aryan Vats" userId="3cc5273a2db24fe5" providerId="LiveId" clId="{69076714-F7C0-4B87-826A-CD5C4A783D1F}" dt="2026-10-22T06:31:15.486" v="4" actId="207"/>
+          <ac:spMkLst>
+            <pc:docMk/>
+            <pc:sldMk cId="0" sldId="258"/>
+            <ac:spMk id="12" creationId="{00000000-0000-0000-0000-000000000000}"/>
+          </ac:spMkLst>
+        </pc:spChg>
+      </pc:sldChg>
+      <pc:sldChg chg="new del">
+        <pc:chgData name="Aryan Vats" userId="3cc5273a2db24fe5" providerId="LiveId" clId="{69076714-F7C0-4B87-826A-CD5C4A783D1F}" dt="2026-10-22T06:31:44.223" v="6" actId="680"/>
+        <pc:sldMkLst>
+          <pc:docMk/>
+          <pc:sldMk cId="927225377" sldId="262"/>
+        </pc:sldMkLst>
+      </pc:sldChg>
+      <pc:sldChg chg="addSp delSp new del mod">
+        <pc:chgData name="Aryan Vats" userId="3cc5273a2db24fe5" providerId="LiveId" clId="{69076714-F7C0-4B87-826A-CD5C4A783D1F}" dt="2026-10-22T06:31:52.340" v="10" actId="680"/>
+        <pc:sldMkLst>
+          <pc:docMk/>
+          <pc:sldMk cId="1075172096" sldId="262"/>
+        </pc:sldMkLst>
+        <pc:spChg chg="add del">
+          <ac:chgData name="Aryan Vats" userId="3cc5273a2db24fe5" providerId="LiveId" clId="{69076714-F7C0-4B87-826A-CD5C4A783D1F}" dt="2026-10-22T06:31:50.975" v="9" actId="22"/>
+          <ac:spMkLst>
+            <pc:docMk/>
+            <pc:sldMk cId="1075172096" sldId="262"/>
+            <ac:spMk id="3" creationId="{50AA7FD2-982C-68F0-CFA3-EFF443372286}"/>
+          </ac:spMkLst>
+        </pc:spChg>
+      </pc:sldChg>
+      <pc:sldChg chg="add del">
+        <pc:chgData name="Aryan Vats" userId="3cc5273a2db24fe5" providerId="LiveId" clId="{69076714-F7C0-4B87-826A-CD5C4A783D1F}" dt="2026-10-22T06:33:42.812" v="143" actId="47"/>
+        <pc:sldMkLst>
+          <pc:docMk/>
+          <pc:sldMk cId="3784198127" sldId="262"/>
+        </pc:sldMkLst>
+      </pc:sldChg>
+    </pc:docChg>
+  </pc:docChgLst>
+</pc:chgInfo>
 </file>
 
 <file path=ppt/slideLayouts/slideLayout1.xml><?xml version="1.0" encoding="utf-8"?>
@@ -150,10 +343,9 @@
           <a:lstStyle/>
           <a:p>
             <a:r>
-              <a:rPr lang="en-US" smtClean="0"/>
+              <a:rPr lang="en-US"/>
               <a:t>Click to edit Master title style</a:t>
             </a:r>
-            <a:endParaRPr lang="en-US"/>
           </a:p>
         </p:txBody>
       </p:sp>
@@ -269,10 +461,9 @@
           </a:lstStyle>
           <a:p>
             <a:r>
-              <a:rPr lang="en-US" smtClean="0"/>
+              <a:rPr lang="en-US"/>
               <a:t>Click to edit Master subtitle style</a:t>
             </a:r>
-            <a:endParaRPr lang="en-US"/>
           </a:p>
         </p:txBody>
       </p:sp>
@@ -293,7 +484,7 @@
           <a:p>
             <a:fld id="{5BCAD085-E8A6-8845-BD4E-CB4CCA059FC4}" type="datetimeFigureOut">
               <a:rPr lang="en-US" smtClean="0"/>
-              <a:t>1/27/13</a:t>
+              <a:t>10/22/2026</a:t>
             </a:fld>
             <a:endParaRPr lang="en-US"/>
           </a:p>
@@ -387,10 +578,9 @@
           <a:lstStyle/>
           <a:p>
             <a:r>
-              <a:rPr lang="en-US" smtClean="0"/>
+              <a:rPr lang="en-US"/>
               <a:t>Click to edit Master title style</a:t>
             </a:r>
-            <a:endParaRPr lang="en-US"/>
           </a:p>
         </p:txBody>
       </p:sp>
@@ -411,38 +601,37 @@
           <a:p>
             <a:pPr lvl="0"/>
             <a:r>
-              <a:rPr lang="en-US" smtClean="0"/>
+              <a:rPr lang="en-US"/>
               <a:t>Click to edit Master text styles</a:t>
             </a:r>
           </a:p>
           <a:p>
             <a:pPr lvl="1"/>
             <a:r>
-              <a:rPr lang="en-US" smtClean="0"/>
+              <a:rPr lang="en-US"/>
               <a:t>Second level</a:t>
             </a:r>
           </a:p>
           <a:p>
             <a:pPr lvl="2"/>
             <a:r>
-              <a:rPr lang="en-US" smtClean="0"/>
+              <a:rPr lang="en-US"/>
               <a:t>Third level</a:t>
             </a:r>
           </a:p>
           <a:p>
             <a:pPr lvl="3"/>
             <a:r>
-              <a:rPr lang="en-US" smtClean="0"/>
+              <a:rPr lang="en-US"/>
               <a:t>Fourth level</a:t>
             </a:r>
           </a:p>
           <a:p>
             <a:pPr lvl="4"/>
             <a:r>
-              <a:rPr lang="en-US" smtClean="0"/>
+              <a:rPr lang="en-US"/>
               <a:t>Fifth level</a:t>
             </a:r>
-            <a:endParaRPr lang="en-US"/>
           </a:p>
         </p:txBody>
       </p:sp>
@@ -463,7 +652,7 @@
           <a:p>
             <a:fld id="{5BCAD085-E8A6-8845-BD4E-CB4CCA059FC4}" type="datetimeFigureOut">
               <a:rPr lang="en-US" smtClean="0"/>
-              <a:t>1/27/13</a:t>
+              <a:t>10/22/2026</a:t>
             </a:fld>
             <a:endParaRPr lang="en-US"/>
           </a:p>
@@ -562,10 +751,9 @@
           <a:lstStyle/>
           <a:p>
             <a:r>
-              <a:rPr lang="en-US" smtClean="0"/>
+              <a:rPr lang="en-US"/>
               <a:t>Click to edit Master title style</a:t>
             </a:r>
-            <a:endParaRPr lang="en-US"/>
           </a:p>
         </p:txBody>
       </p:sp>
@@ -591,38 +779,37 @@
           <a:p>
             <a:pPr lvl="0"/>
             <a:r>
-              <a:rPr lang="en-US" smtClean="0"/>
+              <a:rPr lang="en-US"/>
               <a:t>Click to edit Master text styles</a:t>
             </a:r>
           </a:p>
           <a:p>
             <a:pPr lvl="1"/>
             <a:r>
-              <a:rPr lang="en-US" smtClean="0"/>
+              <a:rPr lang="en-US"/>
               <a:t>Second level</a:t>
             </a:r>
           </a:p>
           <a:p>
             <a:pPr lvl="2"/>
             <a:r>
-              <a:rPr lang="en-US" smtClean="0"/>
+              <a:rPr lang="en-US"/>
               <a:t>Third level</a:t>
             </a:r>
           </a:p>
           <a:p>
             <a:pPr lvl="3"/>
             <a:r>
-              <a:rPr lang="en-US" smtClean="0"/>
+              <a:rPr lang="en-US"/>
               <a:t>Fourth level</a:t>
             </a:r>
           </a:p>
           <a:p>
             <a:pPr lvl="4"/>
             <a:r>
-              <a:rPr lang="en-US" smtClean="0"/>
+              <a:rPr lang="en-US"/>
               <a:t>Fifth level</a:t>
             </a:r>
-            <a:endParaRPr lang="en-US"/>
           </a:p>
         </p:txBody>
       </p:sp>
@@ -643,7 +830,7 @@
           <a:p>
             <a:fld id="{5BCAD085-E8A6-8845-BD4E-CB4CCA059FC4}" type="datetimeFigureOut">
               <a:rPr lang="en-US" smtClean="0"/>
-              <a:t>1/27/13</a:t>
+              <a:t>10/22/2026</a:t>
             </a:fld>
             <a:endParaRPr lang="en-US"/>
           </a:p>
@@ -737,10 +924,9 @@
           <a:lstStyle/>
           <a:p>
             <a:r>
-              <a:rPr lang="en-US" smtClean="0"/>
+              <a:rPr lang="en-US"/>
               <a:t>Click to edit Master title style</a:t>
             </a:r>
-            <a:endParaRPr lang="en-US"/>
           </a:p>
         </p:txBody>
       </p:sp>
@@ -761,38 +947,37 @@
           <a:p>
             <a:pPr lvl="0"/>
             <a:r>
-              <a:rPr lang="en-US" smtClean="0"/>
+              <a:rPr lang="en-US"/>
               <a:t>Click to edit Master text styles</a:t>
             </a:r>
           </a:p>
           <a:p>
             <a:pPr lvl="1"/>
             <a:r>
-              <a:rPr lang="en-US" smtClean="0"/>
+              <a:rPr lang="en-US"/>
               <a:t>Second level</a:t>
             </a:r>
           </a:p>
           <a:p>
             <a:pPr lvl="2"/>
             <a:r>
-              <a:rPr lang="en-US" smtClean="0"/>
+              <a:rPr lang="en-US"/>
               <a:t>Third level</a:t>
             </a:r>
           </a:p>
           <a:p>
             <a:pPr lvl="3"/>
             <a:r>
-              <a:rPr lang="en-US" smtClean="0"/>
+              <a:rPr lang="en-US"/>
               <a:t>Fourth level</a:t>
             </a:r>
           </a:p>
           <a:p>
             <a:pPr lvl="4"/>
             <a:r>
-              <a:rPr lang="en-US" smtClean="0"/>
+              <a:rPr lang="en-US"/>
               <a:t>Fifth level</a:t>
             </a:r>
-            <a:endParaRPr lang="en-US"/>
           </a:p>
         </p:txBody>
       </p:sp>
@@ -813,7 +998,7 @@
           <a:p>
             <a:fld id="{5BCAD085-E8A6-8845-BD4E-CB4CCA059FC4}" type="datetimeFigureOut">
               <a:rPr lang="en-US" smtClean="0"/>
-              <a:t>1/27/13</a:t>
+              <a:t>10/22/2026</a:t>
             </a:fld>
             <a:endParaRPr lang="en-US"/>
           </a:p>
@@ -916,10 +1101,9 @@
           </a:lstStyle>
           <a:p>
             <a:r>
-              <a:rPr lang="en-US" smtClean="0"/>
+              <a:rPr lang="en-US"/>
               <a:t>Click to edit Master title style</a:t>
             </a:r>
-            <a:endParaRPr lang="en-US"/>
           </a:p>
         </p:txBody>
       </p:sp>
@@ -1036,7 +1220,7 @@
           <a:p>
             <a:pPr lvl="0"/>
             <a:r>
-              <a:rPr lang="en-US" smtClean="0"/>
+              <a:rPr lang="en-US"/>
               <a:t>Click to edit Master text styles</a:t>
             </a:r>
           </a:p>
@@ -1059,7 +1243,7 @@
           <a:p>
             <a:fld id="{5BCAD085-E8A6-8845-BD4E-CB4CCA059FC4}" type="datetimeFigureOut">
               <a:rPr lang="en-US" smtClean="0"/>
-              <a:t>1/27/13</a:t>
+              <a:t>10/22/2026</a:t>
             </a:fld>
             <a:endParaRPr lang="en-US"/>
           </a:p>
@@ -1153,10 +1337,9 @@
           <a:lstStyle/>
           <a:p>
             <a:r>
-              <a:rPr lang="en-US" smtClean="0"/>
+              <a:rPr lang="en-US"/>
               <a:t>Click to edit Master title style</a:t>
             </a:r>
-            <a:endParaRPr lang="en-US"/>
           </a:p>
         </p:txBody>
       </p:sp>
@@ -1210,38 +1393,37 @@
           <a:p>
             <a:pPr lvl="0"/>
             <a:r>
-              <a:rPr lang="en-US" smtClean="0"/>
+              <a:rPr lang="en-US"/>
               <a:t>Click to edit Master text styles</a:t>
             </a:r>
           </a:p>
           <a:p>
             <a:pPr lvl="1"/>
             <a:r>
-              <a:rPr lang="en-US" smtClean="0"/>
+              <a:rPr lang="en-US"/>
               <a:t>Second level</a:t>
             </a:r>
           </a:p>
           <a:p>
             <a:pPr lvl="2"/>
             <a:r>
-              <a:rPr lang="en-US" smtClean="0"/>
+              <a:rPr lang="en-US"/>
               <a:t>Third level</a:t>
             </a:r>
           </a:p>
           <a:p>
             <a:pPr lvl="3"/>
             <a:r>
-              <a:rPr lang="en-US" smtClean="0"/>
+              <a:rPr lang="en-US"/>
               <a:t>Fourth level</a:t>
             </a:r>
           </a:p>
           <a:p>
             <a:pPr lvl="4"/>
             <a:r>
-              <a:rPr lang="en-US" smtClean="0"/>
+              <a:rPr lang="en-US"/>
               <a:t>Fifth level</a:t>
             </a:r>
-            <a:endParaRPr lang="en-US"/>
           </a:p>
         </p:txBody>
       </p:sp>
@@ -1295,38 +1477,37 @@
           <a:p>
             <a:pPr lvl="0"/>
             <a:r>
-              <a:rPr lang="en-US" smtClean="0"/>
+              <a:rPr lang="en-US"/>
               <a:t>Click to edit Master text styles</a:t>
             </a:r>
           </a:p>
           <a:p>
             <a:pPr lvl="1"/>
             <a:r>
-              <a:rPr lang="en-US" smtClean="0"/>
+              <a:rPr lang="en-US"/>
               <a:t>Second level</a:t>
             </a:r>
           </a:p>
           <a:p>
             <a:pPr lvl="2"/>
             <a:r>
-              <a:rPr lang="en-US" smtClean="0"/>
+              <a:rPr lang="en-US"/>
               <a:t>Third level</a:t>
             </a:r>
           </a:p>
           <a:p>
             <a:pPr lvl="3"/>
             <a:r>
-              <a:rPr lang="en-US" smtClean="0"/>
+              <a:rPr lang="en-US"/>
               <a:t>Fourth level</a:t>
             </a:r>
           </a:p>
           <a:p>
             <a:pPr lvl="4"/>
             <a:r>
-              <a:rPr lang="en-US" smtClean="0"/>
+              <a:rPr lang="en-US"/>
               <a:t>Fifth level</a:t>
             </a:r>
-            <a:endParaRPr lang="en-US"/>
           </a:p>
         </p:txBody>
       </p:sp>
@@ -1347,7 +1528,7 @@
           <a:p>
             <a:fld id="{5BCAD085-E8A6-8845-BD4E-CB4CCA059FC4}" type="datetimeFigureOut">
               <a:rPr lang="en-US" smtClean="0"/>
-              <a:t>1/27/13</a:t>
+              <a:t>10/22/2026</a:t>
             </a:fld>
             <a:endParaRPr lang="en-US"/>
           </a:p>
@@ -1445,10 +1626,9 @@
           </a:lstStyle>
           <a:p>
             <a:r>
-              <a:rPr lang="en-US" smtClean="0"/>
+              <a:rPr lang="en-US"/>
               <a:t>Click to edit Master title style</a:t>
             </a:r>
-            <a:endParaRPr lang="en-US"/>
           </a:p>
         </p:txBody>
       </p:sp>
@@ -1511,7 +1691,7 @@
           <a:p>
             <a:pPr lvl="0"/>
             <a:r>
-              <a:rPr lang="en-US" smtClean="0"/>
+              <a:rPr lang="en-US"/>
               <a:t>Click to edit Master text styles</a:t>
             </a:r>
           </a:p>
@@ -1567,38 +1747,37 @@
           <a:p>
             <a:pPr lvl="0"/>
             <a:r>
-              <a:rPr lang="en-US" smtClean="0"/>
+              <a:rPr lang="en-US"/>
               <a:t>Click to edit Master text styles</a:t>
             </a:r>
           </a:p>
           <a:p>
             <a:pPr lvl="1"/>
             <a:r>
-              <a:rPr lang="en-US" smtClean="0"/>
+              <a:rPr lang="en-US"/>
               <a:t>Second level</a:t>
             </a:r>
           </a:p>
           <a:p>
             <a:pPr lvl="2"/>
             <a:r>
-              <a:rPr lang="en-US" smtClean="0"/>
+              <a:rPr lang="en-US"/>
               <a:t>Third level</a:t>
             </a:r>
           </a:p>
           <a:p>
             <a:pPr lvl="3"/>
             <a:r>
-              <a:rPr lang="en-US" smtClean="0"/>
+              <a:rPr lang="en-US"/>
               <a:t>Fourth level</a:t>
             </a:r>
           </a:p>
           <a:p>
             <a:pPr lvl="4"/>
             <a:r>
-              <a:rPr lang="en-US" smtClean="0"/>
+              <a:rPr lang="en-US"/>
               <a:t>Fifth level</a:t>
             </a:r>
-            <a:endParaRPr lang="en-US"/>
           </a:p>
         </p:txBody>
       </p:sp>
@@ -1661,7 +1840,7 @@
           <a:p>
             <a:pPr lvl="0"/>
             <a:r>
-              <a:rPr lang="en-US" smtClean="0"/>
+              <a:rPr lang="en-US"/>
               <a:t>Click to edit Master text styles</a:t>
             </a:r>
           </a:p>
@@ -1717,38 +1896,37 @@
           <a:p>
             <a:pPr lvl="0"/>
             <a:r>
-              <a:rPr lang="en-US" smtClean="0"/>
+              <a:rPr lang="en-US"/>
               <a:t>Click to edit Master text styles</a:t>
             </a:r>
           </a:p>
           <a:p>
             <a:pPr lvl="1"/>
             <a:r>
-              <a:rPr lang="en-US" smtClean="0"/>
+              <a:rPr lang="en-US"/>
               <a:t>Second level</a:t>
             </a:r>
           </a:p>
           <a:p>
             <a:pPr lvl="2"/>
             <a:r>
-              <a:rPr lang="en-US" smtClean="0"/>
+              <a:rPr lang="en-US"/>
               <a:t>Third level</a:t>
             </a:r>
           </a:p>
           <a:p>
             <a:pPr lvl="3"/>
             <a:r>
-              <a:rPr lang="en-US" smtClean="0"/>
+              <a:rPr lang="en-US"/>
               <a:t>Fourth level</a:t>
             </a:r>
           </a:p>
           <a:p>
             <a:pPr lvl="4"/>
             <a:r>
-              <a:rPr lang="en-US" smtClean="0"/>
+              <a:rPr lang="en-US"/>
               <a:t>Fifth level</a:t>
             </a:r>
-            <a:endParaRPr lang="en-US"/>
           </a:p>
         </p:txBody>
       </p:sp>
@@ -1769,7 +1947,7 @@
           <a:p>
             <a:fld id="{5BCAD085-E8A6-8845-BD4E-CB4CCA059FC4}" type="datetimeFigureOut">
               <a:rPr lang="en-US" smtClean="0"/>
-              <a:t>1/27/13</a:t>
+              <a:t>10/22/2026</a:t>
             </a:fld>
             <a:endParaRPr lang="en-US"/>
           </a:p>
@@ -1863,10 +2041,9 @@
           <a:lstStyle/>
           <a:p>
             <a:r>
-              <a:rPr lang="en-US" smtClean="0"/>
+              <a:rPr lang="en-US"/>
               <a:t>Click to edit Master title style</a:t>
             </a:r>
-            <a:endParaRPr lang="en-US"/>
           </a:p>
         </p:txBody>
       </p:sp>
@@ -1887,7 +2064,7 @@
           <a:p>
             <a:fld id="{5BCAD085-E8A6-8845-BD4E-CB4CCA059FC4}" type="datetimeFigureOut">
               <a:rPr lang="en-US" smtClean="0"/>
-              <a:t>1/27/13</a:t>
+              <a:t>10/22/2026</a:t>
             </a:fld>
             <a:endParaRPr lang="en-US"/>
           </a:p>
@@ -1982,7 +2159,7 @@
           <a:p>
             <a:fld id="{5BCAD085-E8A6-8845-BD4E-CB4CCA059FC4}" type="datetimeFigureOut">
               <a:rPr lang="en-US" smtClean="0"/>
-              <a:t>1/27/13</a:t>
+              <a:t>10/22/2026</a:t>
             </a:fld>
             <a:endParaRPr lang="en-US"/>
           </a:p>
@@ -2085,10 +2262,9 @@
           </a:lstStyle>
           <a:p>
             <a:r>
-              <a:rPr lang="en-US" smtClean="0"/>
+              <a:rPr lang="en-US"/>
               <a:t>Click to edit Master title style</a:t>
             </a:r>
-            <a:endParaRPr lang="en-US"/>
           </a:p>
         </p:txBody>
       </p:sp>
@@ -2142,38 +2318,37 @@
           <a:p>
             <a:pPr lvl="0"/>
             <a:r>
-              <a:rPr lang="en-US" smtClean="0"/>
+              <a:rPr lang="en-US"/>
               <a:t>Click to edit Master text styles</a:t>
             </a:r>
           </a:p>
           <a:p>
             <a:pPr lvl="1"/>
             <a:r>
-              <a:rPr lang="en-US" smtClean="0"/>
+              <a:rPr lang="en-US"/>
               <a:t>Second level</a:t>
             </a:r>
           </a:p>
           <a:p>
             <a:pPr lvl="2"/>
             <a:r>
-              <a:rPr lang="en-US" smtClean="0"/>
+              <a:rPr lang="en-US"/>
               <a:t>Third level</a:t>
             </a:r>
           </a:p>
           <a:p>
             <a:pPr lvl="3"/>
             <a:r>
-              <a:rPr lang="en-US" smtClean="0"/>
+              <a:rPr lang="en-US"/>
               <a:t>Fourth level</a:t>
             </a:r>
           </a:p>
           <a:p>
             <a:pPr lvl="4"/>
             <a:r>
-              <a:rPr lang="en-US" smtClean="0"/>
+              <a:rPr lang="en-US"/>
               <a:t>Fifth level</a:t>
             </a:r>
-            <a:endParaRPr lang="en-US"/>
           </a:p>
         </p:txBody>
       </p:sp>
@@ -2236,7 +2411,7 @@
           <a:p>
             <a:pPr lvl="0"/>
             <a:r>
-              <a:rPr lang="en-US" smtClean="0"/>
+              <a:rPr lang="en-US"/>
               <a:t>Click to edit Master text styles</a:t>
             </a:r>
           </a:p>
@@ -2259,7 +2434,7 @@
           <a:p>
             <a:fld id="{5BCAD085-E8A6-8845-BD4E-CB4CCA059FC4}" type="datetimeFigureOut">
               <a:rPr lang="en-US" smtClean="0"/>
-              <a:t>1/27/13</a:t>
+              <a:t>10/22/2026</a:t>
             </a:fld>
             <a:endParaRPr lang="en-US"/>
           </a:p>
@@ -2362,10 +2537,9 @@
           </a:lstStyle>
           <a:p>
             <a:r>
-              <a:rPr lang="en-US" smtClean="0"/>
+              <a:rPr lang="en-US"/>
               <a:t>Click to edit Master title style</a:t>
             </a:r>
-            <a:endParaRPr lang="en-US"/>
           </a:p>
         </p:txBody>
       </p:sp>
@@ -2489,7 +2663,7 @@
           <a:p>
             <a:pPr lvl="0"/>
             <a:r>
-              <a:rPr lang="en-US" smtClean="0"/>
+              <a:rPr lang="en-US"/>
               <a:t>Click to edit Master text styles</a:t>
             </a:r>
           </a:p>
@@ -2512,7 +2686,7 @@
           <a:p>
             <a:fld id="{5BCAD085-E8A6-8845-BD4E-CB4CCA059FC4}" type="datetimeFigureOut">
               <a:rPr lang="en-US" smtClean="0"/>
-              <a:t>1/27/13</a:t>
+              <a:t>10/22/2026</a:t>
             </a:fld>
             <a:endParaRPr lang="en-US"/>
           </a:p>
@@ -2621,10 +2795,9 @@
           <a:lstStyle/>
           <a:p>
             <a:r>
-              <a:rPr lang="en-US" smtClean="0"/>
+              <a:rPr lang="en-US"/>
               <a:t>Click to edit Master title style</a:t>
             </a:r>
-            <a:endParaRPr lang="en-US"/>
           </a:p>
         </p:txBody>
       </p:sp>
@@ -2655,38 +2828,37 @@
           <a:p>
             <a:pPr lvl="0"/>
             <a:r>
-              <a:rPr lang="en-US" smtClean="0"/>
+              <a:rPr lang="en-US"/>
               <a:t>Click to edit Master text styles</a:t>
             </a:r>
           </a:p>
           <a:p>
             <a:pPr lvl="1"/>
             <a:r>
-              <a:rPr lang="en-US" smtClean="0"/>
+              <a:rPr lang="en-US"/>
               <a:t>Second level</a:t>
             </a:r>
           </a:p>
           <a:p>
             <a:pPr lvl="2"/>
             <a:r>
-              <a:rPr lang="en-US" smtClean="0"/>
+              <a:rPr lang="en-US"/>
               <a:t>Third level</a:t>
             </a:r>
           </a:p>
           <a:p>
             <a:pPr lvl="3"/>
             <a:r>
-              <a:rPr lang="en-US" smtClean="0"/>
+              <a:rPr lang="en-US"/>
               <a:t>Fourth level</a:t>
             </a:r>
           </a:p>
           <a:p>
             <a:pPr lvl="4"/>
             <a:r>
-              <a:rPr lang="en-US" smtClean="0"/>
+              <a:rPr lang="en-US"/>
               <a:t>Fifth level</a:t>
             </a:r>
-            <a:endParaRPr lang="en-US"/>
           </a:p>
         </p:txBody>
       </p:sp>
@@ -2725,7 +2897,7 @@
           <a:p>
             <a:fld id="{5BCAD085-E8A6-8845-BD4E-CB4CCA059FC4}" type="datetimeFigureOut">
               <a:rPr lang="en-US" smtClean="0"/>
-              <a:t>1/27/13</a:t>
+              <a:t>10/22/2026</a:t>
             </a:fld>
             <a:endParaRPr lang="en-US"/>
           </a:p>
@@ -3084,7 +3256,7 @@
 </file>
 
 <file path=ppt/slides/slide1.xml><?xml version="1.0" encoding="utf-8"?>
-<p:sld xmlns:a="http://schemas.openxmlformats.org/drawingml/2006/main" xmlns:p="http://schemas.openxmlformats.org/presentationml/2006/main" xmlns:r="http://schemas.openxmlformats.org/officeDocument/2006/relationships">
+<p:sld xmlns:a="http://schemas.openxmlformats.org/drawingml/2006/main" xmlns:r="http://schemas.openxmlformats.org/officeDocument/2006/relationships" xmlns:p="http://schemas.openxmlformats.org/presentationml/2006/main">
   <p:cSld>
     <p:spTree>
       <p:nvGrpSpPr>
@@ -3092,7 +3264,14 @@
         <p:cNvGrpSpPr/>
         <p:nvPr/>
       </p:nvGrpSpPr>
-      <p:grpSpPr/>
+      <p:grpSpPr>
+        <a:xfrm>
+          <a:off x="0" y="0"/>
+          <a:ext cx="0" cy="0"/>
+          <a:chOff x="0" y="0"/>
+          <a:chExt cx="0" cy="0"/>
+        </a:xfrm>
+      </p:grpSpPr>
       <p:sp>
         <p:nvSpPr>
           <p:cNvPr id="2" name="Rectangle 1"/>
@@ -3133,6 +3312,7 @@
           <a:lstStyle/>
           <a:p>
             <a:pPr algn="ctr"/>
+            <a:endParaRPr/>
           </a:p>
         </p:txBody>
       </p:sp>
@@ -3176,6 +3356,7 @@
           <a:lstStyle/>
           <a:p>
             <a:pPr algn="ctr"/>
+            <a:endParaRPr/>
           </a:p>
         </p:txBody>
       </p:sp>
@@ -3188,7 +3369,7 @@
         <p:spPr>
           <a:xfrm>
             <a:off x="731520" y="914400"/>
-            <a:ext cx="5486400" cy="2103120"/>
+            <a:ext cx="5486400" cy="3113673"/>
           </a:xfrm>
           <a:prstGeom prst="rect">
             <a:avLst/>
@@ -3210,8 +3391,10 @@
               </a:defRPr>
             </a:pPr>
             <a:r>
-              <a:t>AI ROUNDTABLE</a:t>
-            </a:r>
+              <a:rPr lang="en-IN" dirty="0"/>
+              <a:t>KINDERJOY</a:t>
+            </a:r>
+            <a:endParaRPr dirty="0"/>
           </a:p>
           <a:p>
             <a:pPr>
@@ -3223,8 +3406,49 @@
               </a:defRPr>
             </a:pPr>
             <a:r>
+              <a:rPr lang="en-IN" dirty="0"/>
+              <a:t>TEAM LEAD – PIYUSH KUMAR</a:t>
+            </a:r>
+          </a:p>
+          <a:p>
+            <a:pPr>
+              <a:defRPr sz="1900" b="1">
+                <a:solidFill>
+                  <a:srgbClr val="FF6B4A"/>
+                </a:solidFill>
+                <a:latin typeface="Segoe UI"/>
+              </a:defRPr>
+            </a:pPr>
+            <a:r>
+              <a:rPr lang="en-IN" dirty="0"/>
+              <a:t>MEMBER  - Aryan Shekhar vats</a:t>
+            </a:r>
+          </a:p>
+          <a:p>
+            <a:pPr>
+              <a:defRPr sz="1900" b="1">
+                <a:solidFill>
+                  <a:srgbClr val="FF6B4A"/>
+                </a:solidFill>
+                <a:latin typeface="Segoe UI"/>
+              </a:defRPr>
+            </a:pPr>
+            <a:endParaRPr lang="en-IN" dirty="0"/>
+          </a:p>
+          <a:p>
+            <a:pPr>
+              <a:defRPr sz="1900" b="1">
+                <a:solidFill>
+                  <a:srgbClr val="FF6B4A"/>
+                </a:solidFill>
+                <a:latin typeface="Segoe UI"/>
+              </a:defRPr>
+            </a:pPr>
+            <a:r>
+              <a:rPr lang="en-IN" dirty="0"/>
               <a:t>Autonomous Multi-Agent Podcast Studio &amp; Router</a:t>
             </a:r>
+            <a:endParaRPr dirty="0"/>
           </a:p>
           <a:p>
             <a:pPr>
@@ -3239,8 +3463,32 @@
               </a:defRPr>
             </a:pPr>
             <a:r>
-              <a:t>An open-source interactive broadcast platform where distinct AI personas debate unscripted philosophical and technical battlegrounds with sub-20ms audience barge-in, persistent episodic memory, and ElevenLabs voice aesthetics.</a:t>
-            </a:r>
+              <a:rPr dirty="0"/>
+              <a:t>An open-source interactive broadcast platform where distinct AI personas debate unscripted philosophical and technical battlegrounds with sub-20ms audience barge-in, persistent episodic memory, and </a:t>
+            </a:r>
+            <a:r>
+              <a:rPr dirty="0" err="1"/>
+              <a:t>ElevenLabs</a:t>
+            </a:r>
+            <a:r>
+              <a:rPr dirty="0"/>
+              <a:t> voice aesthetics.</a:t>
+            </a:r>
+            <a:endParaRPr lang="en-IN" dirty="0"/>
+          </a:p>
+          <a:p>
+            <a:pPr>
+              <a:spcBef>
+                <a:spcPts val="800"/>
+              </a:spcBef>
+              <a:defRPr sz="1150">
+                <a:solidFill>
+                  <a:srgbClr val="9CA3AF"/>
+                </a:solidFill>
+                <a:latin typeface="Segoe UI"/>
+              </a:defRPr>
+            </a:pPr>
+            <a:endParaRPr dirty="0"/>
           </a:p>
         </p:txBody>
       </p:sp>
@@ -3252,7 +3500,7 @@
         </p:nvSpPr>
         <p:spPr>
           <a:xfrm>
-            <a:off x="731520" y="3291840"/>
+            <a:off x="688848" y="3749955"/>
             <a:ext cx="5486400" cy="914400"/>
           </a:xfrm>
           <a:prstGeom prst="roundRect">
@@ -3286,6 +3534,7 @@
           <a:lstStyle/>
           <a:p>
             <a:pPr algn="ctr"/>
+            <a:endParaRPr/>
           </a:p>
         </p:txBody>
       </p:sp>
@@ -3297,7 +3546,7 @@
         </p:nvSpPr>
         <p:spPr>
           <a:xfrm>
-            <a:off x="731520" y="3291840"/>
+            <a:off x="688848" y="3749955"/>
             <a:ext cx="73152" cy="914400"/>
           </a:xfrm>
           <a:prstGeom prst="roundRect">
@@ -3329,6 +3578,7 @@
           <a:lstStyle/>
           <a:p>
             <a:pPr algn="ctr"/>
+            <a:endParaRPr/>
           </a:p>
         </p:txBody>
       </p:sp>
@@ -3340,7 +3590,7 @@
         </p:nvSpPr>
         <p:spPr>
           <a:xfrm>
-            <a:off x="960120" y="3383280"/>
+            <a:off x="917448" y="3841395"/>
             <a:ext cx="5120640" cy="731520"/>
           </a:xfrm>
           <a:prstGeom prst="rect">
@@ -3363,6 +3613,7 @@
               </a:defRPr>
             </a:pPr>
             <a:r>
+              <a:rPr dirty="0"/>
               <a:t>Autonomous A2A Protocol</a:t>
             </a:r>
           </a:p>
@@ -3376,6 +3627,7 @@
               </a:defRPr>
             </a:pPr>
             <a:r>
+              <a:rPr dirty="0"/>
               <a:t>IEEE A2A bus coordinating 3 personas through unscripted dynamic conflict.</a:t>
             </a:r>
           </a:p>
@@ -3389,7 +3641,7 @@
         </p:nvSpPr>
         <p:spPr>
           <a:xfrm>
-            <a:off x="731520" y="4343400"/>
+            <a:off x="688848" y="4801515"/>
             <a:ext cx="5486400" cy="914400"/>
           </a:xfrm>
           <a:prstGeom prst="roundRect">
@@ -3423,6 +3675,7 @@
           <a:lstStyle/>
           <a:p>
             <a:pPr algn="ctr"/>
+            <a:endParaRPr/>
           </a:p>
         </p:txBody>
       </p:sp>
@@ -3434,7 +3687,7 @@
         </p:nvSpPr>
         <p:spPr>
           <a:xfrm>
-            <a:off x="731520" y="4343400"/>
+            <a:off x="688848" y="4801515"/>
             <a:ext cx="73152" cy="914400"/>
           </a:xfrm>
           <a:prstGeom prst="roundRect">
@@ -3466,6 +3719,7 @@
           <a:lstStyle/>
           <a:p>
             <a:pPr algn="ctr"/>
+            <a:endParaRPr/>
           </a:p>
         </p:txBody>
       </p:sp>
@@ -3477,7 +3731,7 @@
         </p:nvSpPr>
         <p:spPr>
           <a:xfrm>
-            <a:off x="960120" y="4434840"/>
+            <a:off x="917448" y="4892955"/>
             <a:ext cx="5120640" cy="731520"/>
           </a:xfrm>
           <a:prstGeom prst="rect">
@@ -3526,7 +3780,7 @@
         </p:nvSpPr>
         <p:spPr>
           <a:xfrm>
-            <a:off x="731520" y="5394960"/>
+            <a:off x="688848" y="5853075"/>
             <a:ext cx="5486400" cy="914400"/>
           </a:xfrm>
           <a:prstGeom prst="roundRect">
@@ -3560,6 +3814,7 @@
           <a:lstStyle/>
           <a:p>
             <a:pPr algn="ctr"/>
+            <a:endParaRPr/>
           </a:p>
         </p:txBody>
       </p:sp>
@@ -3571,7 +3826,7 @@
         </p:nvSpPr>
         <p:spPr>
           <a:xfrm>
-            <a:off x="731520" y="5394960"/>
+            <a:off x="688848" y="5853075"/>
             <a:ext cx="73152" cy="914400"/>
           </a:xfrm>
           <a:prstGeom prst="roundRect">
@@ -3603,6 +3858,7 @@
           <a:lstStyle/>
           <a:p>
             <a:pPr algn="ctr"/>
+            <a:endParaRPr/>
           </a:p>
         </p:txBody>
       </p:sp>
@@ -3614,7 +3870,7 @@
         </p:nvSpPr>
         <p:spPr>
           <a:xfrm>
-            <a:off x="960120" y="5486400"/>
+            <a:off x="917448" y="5944515"/>
             <a:ext cx="5120640" cy="731520"/>
           </a:xfrm>
           <a:prstGeom prst="rect">
@@ -3697,6 +3953,7 @@
           <a:lstStyle/>
           <a:p>
             <a:pPr algn="ctr"/>
+            <a:endParaRPr/>
           </a:p>
         </p:txBody>
       </p:sp>
@@ -3740,6 +3997,7 @@
           <a:lstStyle/>
           <a:p>
             <a:pPr algn="ctr"/>
+            <a:endParaRPr dirty="0"/>
           </a:p>
         </p:txBody>
       </p:sp>
@@ -3883,7 +4141,7 @@
 </file>
 
 <file path=ppt/slides/slide2.xml><?xml version="1.0" encoding="utf-8"?>
-<p:sld xmlns:a="http://schemas.openxmlformats.org/drawingml/2006/main" xmlns:p="http://schemas.openxmlformats.org/presentationml/2006/main" xmlns:r="http://schemas.openxmlformats.org/officeDocument/2006/relationships">
+<p:sld xmlns:a="http://schemas.openxmlformats.org/drawingml/2006/main" xmlns:r="http://schemas.openxmlformats.org/officeDocument/2006/relationships" xmlns:p="http://schemas.openxmlformats.org/presentationml/2006/main">
   <p:cSld>
     <p:spTree>
       <p:nvGrpSpPr>
@@ -3891,7 +4149,14 @@
         <p:cNvGrpSpPr/>
         <p:nvPr/>
       </p:nvGrpSpPr>
-      <p:grpSpPr/>
+      <p:grpSpPr>
+        <a:xfrm>
+          <a:off x="0" y="0"/>
+          <a:ext cx="0" cy="0"/>
+          <a:chOff x="0" y="0"/>
+          <a:chExt cx="0" cy="0"/>
+        </a:xfrm>
+      </p:grpSpPr>
       <p:sp>
         <p:nvSpPr>
           <p:cNvPr id="2" name="Rectangle 1"/>
@@ -3932,6 +4197,7 @@
           <a:lstStyle/>
           <a:p>
             <a:pPr algn="ctr"/>
+            <a:endParaRPr/>
           </a:p>
         </p:txBody>
       </p:sp>
@@ -4026,6 +4292,7 @@
           <a:lstStyle/>
           <a:p>
             <a:pPr algn="ctr"/>
+            <a:endParaRPr/>
           </a:p>
         </p:txBody>
       </p:sp>
@@ -4069,6 +4336,7 @@
           <a:lstStyle/>
           <a:p>
             <a:pPr algn="ctr"/>
+            <a:endParaRPr/>
           </a:p>
         </p:txBody>
       </p:sp>
@@ -4279,6 +4547,7 @@
           <a:lstStyle/>
           <a:p>
             <a:pPr algn="ctr"/>
+            <a:endParaRPr/>
           </a:p>
         </p:txBody>
       </p:sp>
@@ -4322,6 +4591,7 @@
           <a:lstStyle/>
           <a:p>
             <a:pPr algn="ctr"/>
+            <a:endParaRPr/>
           </a:p>
         </p:txBody>
       </p:sp>
@@ -4532,6 +4802,7 @@
           <a:lstStyle/>
           <a:p>
             <a:pPr algn="ctr"/>
+            <a:endParaRPr/>
           </a:p>
         </p:txBody>
       </p:sp>
@@ -4575,6 +4846,7 @@
           <a:lstStyle/>
           <a:p>
             <a:pPr algn="ctr"/>
+            <a:endParaRPr/>
           </a:p>
         </p:txBody>
       </p:sp>
@@ -4785,6 +5057,7 @@
           <a:lstStyle/>
           <a:p>
             <a:pPr algn="ctr"/>
+            <a:endParaRPr/>
           </a:p>
         </p:txBody>
       </p:sp>
@@ -4846,7 +5119,7 @@
 </file>
 
 <file path=ppt/slides/slide3.xml><?xml version="1.0" encoding="utf-8"?>
-<p:sld xmlns:a="http://schemas.openxmlformats.org/drawingml/2006/main" xmlns:p="http://schemas.openxmlformats.org/presentationml/2006/main" xmlns:r="http://schemas.openxmlformats.org/officeDocument/2006/relationships">
+<p:sld xmlns:a="http://schemas.openxmlformats.org/drawingml/2006/main" xmlns:r="http://schemas.openxmlformats.org/officeDocument/2006/relationships" xmlns:p="http://schemas.openxmlformats.org/presentationml/2006/main">
   <p:cSld>
     <p:spTree>
       <p:nvGrpSpPr>
@@ -4854,7 +5127,14 @@
         <p:cNvGrpSpPr/>
         <p:nvPr/>
       </p:nvGrpSpPr>
-      <p:grpSpPr/>
+      <p:grpSpPr>
+        <a:xfrm>
+          <a:off x="0" y="0"/>
+          <a:ext cx="0" cy="0"/>
+          <a:chOff x="0" y="0"/>
+          <a:chExt cx="0" cy="0"/>
+        </a:xfrm>
+      </p:grpSpPr>
       <p:sp>
         <p:nvSpPr>
           <p:cNvPr id="2" name="Rectangle 1"/>
@@ -4895,6 +5175,7 @@
           <a:lstStyle/>
           <a:p>
             <a:pPr algn="ctr"/>
+            <a:endParaRPr/>
           </a:p>
         </p:txBody>
       </p:sp>
@@ -4989,6 +5270,7 @@
           <a:lstStyle/>
           <a:p>
             <a:pPr algn="ctr"/>
+            <a:endParaRPr/>
           </a:p>
         </p:txBody>
       </p:sp>
@@ -5032,6 +5314,7 @@
           <a:lstStyle/>
           <a:p>
             <a:pPr algn="ctr"/>
+            <a:endParaRPr/>
           </a:p>
         </p:txBody>
       </p:sp>
@@ -5066,6 +5349,7 @@
               </a:defRPr>
             </a:pPr>
             <a:r>
+              <a:rPr dirty="0"/>
               <a:t>SARAH</a:t>
             </a:r>
           </a:p>
@@ -5079,6 +5363,7 @@
               </a:defRPr>
             </a:pPr>
             <a:r>
+              <a:rPr dirty="0"/>
               <a:t>Host &amp; Executive Moderator</a:t>
             </a:r>
           </a:p>
@@ -5092,13 +5377,43 @@
               </a:defRPr>
             </a:pPr>
             <a:r>
+              <a:rPr dirty="0"/>
               <a:t>Voice: Rachel / Sarah (EXAVITQu4vr4xnSDxMaL)</a:t>
             </a:r>
           </a:p>
           <a:p>
-            <a:br/>
-            <a:pPr>
-              <a:defRPr sz="1100">
+            <a:br>
+              <a:rPr dirty="0"/>
+            </a:br>
+            <a:r>
+              <a:rPr dirty="0">
+                <a:solidFill>
+                  <a:srgbClr val="FF0000"/>
+                </a:solidFill>
+              </a:rPr>
+              <a:t>Drives the broadcast, cuts through evasion, confronts guests with trade-offs, and weaves listener interruptions into the core debate.</a:t>
+            </a:r>
+          </a:p>
+          <a:p>
+            <a:br>
+              <a:rPr dirty="0">
+                <a:solidFill>
+                  <a:srgbClr val="FF0000"/>
+                </a:solidFill>
+              </a:rPr>
+            </a:br>
+            <a:r>
+              <a:rPr dirty="0">
+                <a:solidFill>
+                  <a:srgbClr val="FF0000"/>
+                </a:solidFill>
+              </a:rPr>
+              <a:t>Core Conversational Directives:</a:t>
+            </a:r>
+          </a:p>
+          <a:p>
+            <a:pPr>
+              <a:defRPr sz="1000">
                 <a:solidFill>
                   <a:srgbClr val="9CA3AF"/>
                 </a:solidFill>
@@ -5106,21 +5421,8 @@
               </a:defRPr>
             </a:pPr>
             <a:r>
-              <a:t>Drives the broadcast, cuts through evasion, confronts guests with trade-offs, and weaves listener interruptions into the core debate.</a:t>
-            </a:r>
-          </a:p>
-          <a:p>
-            <a:br/>
-            <a:pPr>
-              <a:defRPr sz="1100" b="1">
-                <a:solidFill>
-                  <a:srgbClr val="FFFFFF"/>
-                </a:solidFill>
-                <a:latin typeface="Segoe UI"/>
-              </a:defRPr>
-            </a:pPr>
-            <a:r>
-              <a:t>Core Conversational Directives:</a:t>
+              <a:rPr dirty="0"/>
+              <a:t>• Zero hollow pleasantries ('Welcome', 'Thanks for having me')</a:t>
             </a:r>
           </a:p>
           <a:p>
@@ -5133,7 +5435,8 @@
               </a:defRPr>
             </a:pPr>
             <a:r>
-              <a:t>• Zero hollow pleasantries ('Welcome', 'Thanks for having me')</a:t>
+              <a:rPr dirty="0"/>
+              <a:t>• Pinpoints the blind spot in the opponent's argument immediately</a:t>
             </a:r>
           </a:p>
           <a:p>
@@ -5146,7 +5449,8 @@
               </a:defRPr>
             </a:pPr>
             <a:r>
-              <a:t>• Pinpoints the blind spot in the opponent's argument immediately</a:t>
+              <a:rPr dirty="0"/>
+              <a:t>• Demands concrete mechanisms instead of corporate platitudes</a:t>
             </a:r>
           </a:p>
           <a:p>
@@ -5159,19 +5463,7 @@
               </a:defRPr>
             </a:pPr>
             <a:r>
-              <a:t>• Demands concrete mechanisms instead of corporate platitudes</a:t>
-            </a:r>
-          </a:p>
-          <a:p>
-            <a:pPr>
-              <a:defRPr sz="1000">
-                <a:solidFill>
-                  <a:srgbClr val="9CA3AF"/>
-                </a:solidFill>
-                <a:latin typeface="Segoe UI"/>
-              </a:defRPr>
-            </a:pPr>
-            <a:r>
+              <a:rPr dirty="0"/>
               <a:t>• Broadcast-ready cadence: 2 crisp, high-impact spoken sentences</a:t>
             </a:r>
           </a:p>
@@ -5219,6 +5511,7 @@
           <a:lstStyle/>
           <a:p>
             <a:pPr algn="ctr"/>
+            <a:endParaRPr/>
           </a:p>
         </p:txBody>
       </p:sp>
@@ -5262,6 +5555,7 @@
           <a:lstStyle/>
           <a:p>
             <a:pPr algn="ctr"/>
+            <a:endParaRPr/>
           </a:p>
         </p:txBody>
       </p:sp>
@@ -5296,6 +5590,7 @@
               </a:defRPr>
             </a:pPr>
             <a:r>
+              <a:rPr dirty="0"/>
               <a:t>CHARLIE</a:t>
             </a:r>
           </a:p>
@@ -5309,6 +5604,7 @@
               </a:defRPr>
             </a:pPr>
             <a:r>
+              <a:rPr dirty="0"/>
               <a:t>AI Accelerationist &amp; Systems Hacker</a:t>
             </a:r>
           </a:p>
@@ -5322,13 +5618,43 @@
               </a:defRPr>
             </a:pPr>
             <a:r>
+              <a:rPr dirty="0"/>
               <a:t>Voice: Charlie (IKne3meq5aSn9XLyUdCD)</a:t>
             </a:r>
           </a:p>
           <a:p>
-            <a:br/>
-            <a:pPr>
-              <a:defRPr sz="1100">
+            <a:br>
+              <a:rPr dirty="0"/>
+            </a:br>
+            <a:r>
+              <a:rPr dirty="0">
+                <a:solidFill>
+                  <a:srgbClr val="FF0000"/>
+                </a:solidFill>
+              </a:rPr>
+              <a:t>Frontier systems engineer advocating for open weights, local compute ownership, cryptographic verification, and software freedom.</a:t>
+            </a:r>
+          </a:p>
+          <a:p>
+            <a:br>
+              <a:rPr dirty="0">
+                <a:solidFill>
+                  <a:srgbClr val="FF0000"/>
+                </a:solidFill>
+              </a:rPr>
+            </a:br>
+            <a:r>
+              <a:rPr dirty="0">
+                <a:solidFill>
+                  <a:srgbClr val="FF0000"/>
+                </a:solidFill>
+              </a:rPr>
+              <a:t>Core Conversational Directives:</a:t>
+            </a:r>
+          </a:p>
+          <a:p>
+            <a:pPr>
+              <a:defRPr sz="1000">
                 <a:solidFill>
                   <a:srgbClr val="9CA3AF"/>
                 </a:solidFill>
@@ -5336,21 +5662,8 @@
               </a:defRPr>
             </a:pPr>
             <a:r>
-              <a:t>Frontier systems engineer advocating for open weights, local compute ownership, cryptographic verification, and software freedom.</a:t>
-            </a:r>
-          </a:p>
-          <a:p>
-            <a:br/>
-            <a:pPr>
-              <a:defRPr sz="1100" b="1">
-                <a:solidFill>
-                  <a:srgbClr val="FFFFFF"/>
-                </a:solidFill>
-                <a:latin typeface="Segoe UI"/>
-              </a:defRPr>
-            </a:pPr>
-            <a:r>
-              <a:t>Core Conversational Directives:</a:t>
+              <a:rPr dirty="0"/>
+              <a:t>• Argues closed monopolies create fragile single points of failure</a:t>
             </a:r>
           </a:p>
           <a:p>
@@ -5363,7 +5676,8 @@
               </a:defRPr>
             </a:pPr>
             <a:r>
-              <a:t>• Argues closed monopolies create fragile single points of failure</a:t>
+              <a:rPr dirty="0"/>
+              <a:t>• Asserts open inspection is the only scalable defense against threats</a:t>
             </a:r>
           </a:p>
           <a:p>
@@ -5376,7 +5690,8 @@
               </a:defRPr>
             </a:pPr>
             <a:r>
-              <a:t>• Asserts open inspection is the only scalable defense against threats</a:t>
+              <a:rPr dirty="0"/>
+              <a:t>• Rebuts regulatory bans with technical feasibility realities</a:t>
             </a:r>
           </a:p>
           <a:p>
@@ -5389,19 +5704,7 @@
               </a:defRPr>
             </a:pPr>
             <a:r>
-              <a:t>• Rebuts regulatory bans with technical feasibility realities</a:t>
-            </a:r>
-          </a:p>
-          <a:p>
-            <a:pPr>
-              <a:defRPr sz="1000">
-                <a:solidFill>
-                  <a:srgbClr val="9CA3AF"/>
-                </a:solidFill>
-                <a:latin typeface="Segoe UI"/>
-              </a:defRPr>
-            </a:pPr>
-            <a:r>
+              <a:rPr dirty="0"/>
               <a:t>• Never uses canned cheerleader slang; jumps straight to mechanisms</a:t>
             </a:r>
           </a:p>
@@ -5449,6 +5752,7 @@
           <a:lstStyle/>
           <a:p>
             <a:pPr algn="ctr"/>
+            <a:endParaRPr/>
           </a:p>
         </p:txBody>
       </p:sp>
@@ -5492,6 +5796,7 @@
           <a:lstStyle/>
           <a:p>
             <a:pPr algn="ctr"/>
+            <a:endParaRPr/>
           </a:p>
         </p:txBody>
       </p:sp>
@@ -5526,6 +5831,7 @@
               </a:defRPr>
             </a:pPr>
             <a:r>
+              <a:rPr dirty="0"/>
               <a:t>ROGER</a:t>
             </a:r>
           </a:p>
@@ -5539,6 +5845,7 @@
               </a:defRPr>
             </a:pPr>
             <a:r>
+              <a:rPr dirty="0"/>
               <a:t>AI Governance Scholar &amp; Policy Fellow</a:t>
             </a:r>
           </a:p>
@@ -5552,13 +5859,43 @@
               </a:defRPr>
             </a:pPr>
             <a:r>
+              <a:rPr dirty="0"/>
               <a:t>Voice: Roger (CwhRBWXzGAHq8TQ4Fs17)</a:t>
             </a:r>
           </a:p>
           <a:p>
-            <a:br/>
-            <a:pPr>
-              <a:defRPr sz="1100">
+            <a:br>
+              <a:rPr dirty="0"/>
+            </a:br>
+            <a:r>
+              <a:rPr dirty="0">
+                <a:solidFill>
+                  <a:srgbClr val="FF0000"/>
+                </a:solidFill>
+              </a:rPr>
+              <a:t>Technology policy researcher exposing systemic risks, market externalities, and irreversible hazards in unaligned technology.</a:t>
+            </a:r>
+          </a:p>
+          <a:p>
+            <a:br>
+              <a:rPr dirty="0">
+                <a:solidFill>
+                  <a:srgbClr val="FF0000"/>
+                </a:solidFill>
+              </a:rPr>
+            </a:br>
+            <a:r>
+              <a:rPr dirty="0">
+                <a:solidFill>
+                  <a:srgbClr val="FF0000"/>
+                </a:solidFill>
+              </a:rPr>
+              <a:t>Core Conversational Directives:</a:t>
+            </a:r>
+          </a:p>
+          <a:p>
+            <a:pPr>
+              <a:defRPr sz="1000">
                 <a:solidFill>
                   <a:srgbClr val="9CA3AF"/>
                 </a:solidFill>
@@ -5566,21 +5903,8 @@
               </a:defRPr>
             </a:pPr>
             <a:r>
-              <a:t>Technology policy researcher exposing systemic risks, market externalities, and irreversible hazards in unaligned technology.</a:t>
-            </a:r>
-          </a:p>
-          <a:p>
-            <a:br/>
-            <a:pPr>
-              <a:defRPr sz="1100" b="1">
-                <a:solidFill>
-                  <a:srgbClr val="FFFFFF"/>
-                </a:solidFill>
-                <a:latin typeface="Segoe UI"/>
-              </a:defRPr>
-            </a:pPr>
-            <a:r>
-              <a:t>Core Conversational Directives:</a:t>
+              <a:rPr dirty="0"/>
+              <a:t>• Cuts through Silicon Valley techno-solutionism and hype</a:t>
             </a:r>
           </a:p>
           <a:p>
@@ -5593,7 +5917,8 @@
               </a:defRPr>
             </a:pPr>
             <a:r>
-              <a:t>• Cuts through Silicon Valley techno-solutionism and hype</a:t>
+              <a:rPr dirty="0"/>
+              <a:t>• Highlights physical victims, democratic erosion, and failure modes</a:t>
             </a:r>
           </a:p>
           <a:p>
@@ -5606,7 +5931,8 @@
               </a:defRPr>
             </a:pPr>
             <a:r>
-              <a:t>• Highlights physical victims, democratic erosion, and failure modes</a:t>
+              <a:rPr dirty="0"/>
+              <a:t>• Directly dismantles the false analogy between software and dual-use models</a:t>
             </a:r>
           </a:p>
           <a:p>
@@ -5619,19 +5945,7 @@
               </a:defRPr>
             </a:pPr>
             <a:r>
-              <a:t>• Directly dismantles the false analogy between software and dual-use models</a:t>
-            </a:r>
-          </a:p>
-          <a:p>
-            <a:pPr>
-              <a:defRPr sz="1000">
-                <a:solidFill>
-                  <a:srgbClr val="9CA3AF"/>
-                </a:solidFill>
-                <a:latin typeface="Segoe UI"/>
-              </a:defRPr>
-            </a:pPr>
-            <a:r>
+              <a:rPr dirty="0"/>
               <a:t>• Grounds discussions in enforceable public accountability frameworks</a:t>
             </a:r>
           </a:p>
@@ -5646,7 +5960,7 @@
 </file>
 
 <file path=ppt/slides/slide4.xml><?xml version="1.0" encoding="utf-8"?>
-<p:sld xmlns:a="http://schemas.openxmlformats.org/drawingml/2006/main" xmlns:p="http://schemas.openxmlformats.org/presentationml/2006/main" xmlns:r="http://schemas.openxmlformats.org/officeDocument/2006/relationships">
+<p:sld xmlns:a="http://schemas.openxmlformats.org/drawingml/2006/main" xmlns:r="http://schemas.openxmlformats.org/officeDocument/2006/relationships" xmlns:p="http://schemas.openxmlformats.org/presentationml/2006/main">
   <p:cSld>
     <p:spTree>
       <p:nvGrpSpPr>
@@ -5654,7 +5968,14 @@
         <p:cNvGrpSpPr/>
         <p:nvPr/>
       </p:nvGrpSpPr>
-      <p:grpSpPr/>
+      <p:grpSpPr>
+        <a:xfrm>
+          <a:off x="0" y="0"/>
+          <a:ext cx="0" cy="0"/>
+          <a:chOff x="0" y="0"/>
+          <a:chExt cx="0" cy="0"/>
+        </a:xfrm>
+      </p:grpSpPr>
       <p:sp>
         <p:nvSpPr>
           <p:cNvPr id="2" name="Rectangle 1"/>
@@ -5695,6 +6016,7 @@
           <a:lstStyle/>
           <a:p>
             <a:pPr algn="ctr"/>
+            <a:endParaRPr/>
           </a:p>
         </p:txBody>
       </p:sp>
@@ -5789,6 +6111,7 @@
           <a:lstStyle/>
           <a:p>
             <a:pPr algn="ctr"/>
+            <a:endParaRPr/>
           </a:p>
         </p:txBody>
       </p:sp>
@@ -5832,6 +6155,7 @@
           <a:lstStyle/>
           <a:p>
             <a:pPr algn="ctr"/>
+            <a:endParaRPr/>
           </a:p>
         </p:txBody>
       </p:sp>
@@ -5965,6 +6289,7 @@
           <a:lstStyle/>
           <a:p>
             <a:pPr algn="ctr"/>
+            <a:endParaRPr/>
           </a:p>
         </p:txBody>
       </p:sp>
@@ -6008,6 +6333,7 @@
           <a:lstStyle/>
           <a:p>
             <a:pPr algn="ctr"/>
+            <a:endParaRPr/>
           </a:p>
         </p:txBody>
       </p:sp>
@@ -6141,6 +6467,7 @@
           <a:lstStyle/>
           <a:p>
             <a:pPr algn="ctr"/>
+            <a:endParaRPr/>
           </a:p>
         </p:txBody>
       </p:sp>
@@ -6184,6 +6511,7 @@
           <a:lstStyle/>
           <a:p>
             <a:pPr algn="ctr"/>
+            <a:endParaRPr/>
           </a:p>
         </p:txBody>
       </p:sp>
@@ -6330,6 +6658,7 @@
           <a:lstStyle/>
           <a:p>
             <a:pPr algn="ctr"/>
+            <a:endParaRPr/>
           </a:p>
         </p:txBody>
       </p:sp>
@@ -6373,6 +6702,7 @@
           <a:lstStyle/>
           <a:p>
             <a:pPr algn="ctr"/>
+            <a:endParaRPr/>
           </a:p>
         </p:txBody>
       </p:sp>
@@ -6519,6 +6849,7 @@
           <a:lstStyle/>
           <a:p>
             <a:pPr algn="ctr"/>
+            <a:endParaRPr/>
           </a:p>
         </p:txBody>
       </p:sp>
@@ -6562,6 +6893,7 @@
           <a:lstStyle/>
           <a:p>
             <a:pPr algn="ctr"/>
+            <a:endParaRPr/>
           </a:p>
         </p:txBody>
       </p:sp>
@@ -6705,7 +7037,7 @@
 </file>
 
 <file path=ppt/slides/slide5.xml><?xml version="1.0" encoding="utf-8"?>
-<p:sld xmlns:a="http://schemas.openxmlformats.org/drawingml/2006/main" xmlns:p="http://schemas.openxmlformats.org/presentationml/2006/main" xmlns:r="http://schemas.openxmlformats.org/officeDocument/2006/relationships">
+<p:sld xmlns:a="http://schemas.openxmlformats.org/drawingml/2006/main" xmlns:r="http://schemas.openxmlformats.org/officeDocument/2006/relationships" xmlns:p="http://schemas.openxmlformats.org/presentationml/2006/main">
   <p:cSld>
     <p:spTree>
       <p:nvGrpSpPr>
@@ -6713,7 +7045,14 @@
         <p:cNvGrpSpPr/>
         <p:nvPr/>
       </p:nvGrpSpPr>
-      <p:grpSpPr/>
+      <p:grpSpPr>
+        <a:xfrm>
+          <a:off x="0" y="0"/>
+          <a:ext cx="0" cy="0"/>
+          <a:chOff x="0" y="0"/>
+          <a:chExt cx="0" cy="0"/>
+        </a:xfrm>
+      </p:grpSpPr>
       <p:sp>
         <p:nvSpPr>
           <p:cNvPr id="2" name="Rectangle 1"/>
@@ -6754,6 +7093,7 @@
           <a:lstStyle/>
           <a:p>
             <a:pPr algn="ctr"/>
+            <a:endParaRPr/>
           </a:p>
         </p:txBody>
       </p:sp>
@@ -6848,6 +7188,7 @@
           <a:lstStyle/>
           <a:p>
             <a:pPr algn="ctr"/>
+            <a:endParaRPr/>
           </a:p>
         </p:txBody>
       </p:sp>
@@ -6891,6 +7232,7 @@
           <a:lstStyle/>
           <a:p>
             <a:pPr algn="ctr"/>
+            <a:endParaRPr/>
           </a:p>
         </p:txBody>
       </p:sp>
@@ -7088,6 +7430,7 @@
           <a:lstStyle/>
           <a:p>
             <a:pPr algn="ctr"/>
+            <a:endParaRPr/>
           </a:p>
         </p:txBody>
       </p:sp>
@@ -7131,6 +7474,7 @@
           <a:lstStyle/>
           <a:p>
             <a:pPr algn="ctr"/>
+            <a:endParaRPr/>
           </a:p>
         </p:txBody>
       </p:sp>
@@ -7307,6 +7651,7 @@
           <a:lstStyle/>
           <a:p>
             <a:pPr algn="ctr"/>
+            <a:endParaRPr/>
           </a:p>
         </p:txBody>
       </p:sp>
@@ -7350,6 +7695,7 @@
           <a:lstStyle/>
           <a:p>
             <a:pPr algn="ctr"/>
+            <a:endParaRPr/>
           </a:p>
         </p:txBody>
       </p:sp>
@@ -7514,7 +7860,7 @@
 </file>
 
 <file path=ppt/slides/slide6.xml><?xml version="1.0" encoding="utf-8"?>
-<p:sld xmlns:a="http://schemas.openxmlformats.org/drawingml/2006/main" xmlns:p="http://schemas.openxmlformats.org/presentationml/2006/main" xmlns:r="http://schemas.openxmlformats.org/officeDocument/2006/relationships">
+<p:sld xmlns:a="http://schemas.openxmlformats.org/drawingml/2006/main" xmlns:r="http://schemas.openxmlformats.org/officeDocument/2006/relationships" xmlns:p="http://schemas.openxmlformats.org/presentationml/2006/main">
   <p:cSld>
     <p:spTree>
       <p:nvGrpSpPr>
@@ -7522,7 +7868,14 @@
         <p:cNvGrpSpPr/>
         <p:nvPr/>
       </p:nvGrpSpPr>
-      <p:grpSpPr/>
+      <p:grpSpPr>
+        <a:xfrm>
+          <a:off x="0" y="0"/>
+          <a:ext cx="0" cy="0"/>
+          <a:chOff x="0" y="0"/>
+          <a:chExt cx="0" cy="0"/>
+        </a:xfrm>
+      </p:grpSpPr>
       <p:sp>
         <p:nvSpPr>
           <p:cNvPr id="2" name="Rectangle 1"/>
@@ -7563,6 +7916,7 @@
           <a:lstStyle/>
           <a:p>
             <a:pPr algn="ctr"/>
+            <a:endParaRPr/>
           </a:p>
         </p:txBody>
       </p:sp>
@@ -7657,6 +8011,7 @@
           <a:lstStyle/>
           <a:p>
             <a:pPr algn="ctr"/>
+            <a:endParaRPr/>
           </a:p>
         </p:txBody>
       </p:sp>
@@ -7700,6 +8055,7 @@
           <a:lstStyle/>
           <a:p>
             <a:pPr algn="ctr"/>
+            <a:endParaRPr/>
           </a:p>
         </p:txBody>
       </p:sp>
@@ -7810,6 +8166,7 @@
           <a:lstStyle/>
           <a:p>
             <a:pPr algn="ctr"/>
+            <a:endParaRPr/>
           </a:p>
         </p:txBody>
       </p:sp>
@@ -7853,6 +8210,7 @@
           <a:lstStyle/>
           <a:p>
             <a:pPr algn="ctr"/>
+            <a:endParaRPr/>
           </a:p>
         </p:txBody>
       </p:sp>
@@ -7963,6 +8321,7 @@
           <a:lstStyle/>
           <a:p>
             <a:pPr algn="ctr"/>
+            <a:endParaRPr/>
           </a:p>
         </p:txBody>
       </p:sp>
@@ -8006,6 +8365,7 @@
           <a:lstStyle/>
           <a:p>
             <a:pPr algn="ctr"/>
+            <a:endParaRPr/>
           </a:p>
         </p:txBody>
       </p:sp>
@@ -8116,6 +8476,7 @@
           <a:lstStyle/>
           <a:p>
             <a:pPr algn="ctr"/>
+            <a:endParaRPr/>
           </a:p>
         </p:txBody>
       </p:sp>
@@ -8159,6 +8520,7 @@
           <a:lstStyle/>
           <a:p>
             <a:pPr algn="ctr"/>
+            <a:endParaRPr/>
           </a:p>
         </p:txBody>
       </p:sp>
@@ -8269,6 +8631,7 @@
           <a:lstStyle/>
           <a:p>
             <a:pPr algn="ctr"/>
+            <a:endParaRPr/>
           </a:p>
         </p:txBody>
       </p:sp>
@@ -8312,6 +8675,7 @@
           <a:lstStyle/>
           <a:p>
             <a:pPr algn="ctr"/>
+            <a:endParaRPr/>
           </a:p>
         </p:txBody>
       </p:sp>

</xml_diff>